<commit_message>
feat(templates): restore violet cover photography
</commit_message>
<xml_diff>
--- a/skills/presentation-template-library/skills/artifact-template-violet-operations/assets/reference.pptx
+++ b/skills/presentation-template-library/skills/artifact-template-violet-operations/assets/reference.pptx
@@ -197,16 +197,6 @@
 <file path=ppt/slides/slide1.xml><?xml version="1.0" encoding="utf-8"?>
 <p:sld xmlns:p="http://schemas.openxmlformats.org/presentationml/2006/main">
   <p:cSld name="Opening claim">
-    <p:bg>
-      <p:bgPr>
-        <a:blipFill xmlns:a="http://schemas.openxmlformats.org/drawingml/2006/main">
-          <a:blip xmlns:r="http://schemas.openxmlformats.org/officeDocument/2006/relationships" r:embed="rIdOfficeKitImage4df9c6298f17ef7a_1"/>
-          <a:stretch>
-            <a:fillRect/>
-          </a:stretch>
-        </a:blipFill>
-      </p:bgPr>
-    </p:bg>
     <p:spTree>
       <p:nvGrpSpPr>
         <p:cNvPr id="1" name=""/>
@@ -223,26 +213,24 @@
       </p:grpSpPr>
       <p:sp>
         <p:nvSpPr>
-          <p:cNvPr id="2" name="cover-paper-scrim"/>
+          <p:cNvPr id="2" name="electric-violet-cover-field"/>
           <p:cNvSpPr/>
           <p:nvPr/>
         </p:nvSpPr>
         <p:spPr>
           <a:xfrm xmlns:a="http://schemas.openxmlformats.org/drawingml/2006/main">
             <a:off x="0" y="0"/>
-            <a:ext cx="9525000" cy="8572500"/>
+            <a:ext cx="15240000" cy="8572500"/>
           </a:xfrm>
           <a:prstGeom xmlns:a="http://schemas.openxmlformats.org/drawingml/2006/main" prst="rect">
             <a:avLst/>
           </a:prstGeom>
           <a:solidFill xmlns:a="http://schemas.openxmlformats.org/drawingml/2006/main">
-            <a:srgbClr val="101115">
-              <a:alpha val="100000"/>
-            </a:srgbClr>
+            <a:srgbClr val="121212"/>
           </a:solidFill>
           <a:ln xmlns:a="http://schemas.openxmlformats.org/drawingml/2006/main" w="0">
             <a:solidFill>
-              <a:srgbClr val="101115"/>
+              <a:srgbClr val="121212"/>
             </a:solidFill>
             <a:prstDash val="solid"/>
           </a:ln>
@@ -259,16 +247,39 @@
           </a:p>
         </p:txBody>
       </p:sp>
-      <p:sp>
-        <p:nvSpPr>
-          <p:cNvPr id="3" name="top-rule"/>
+      <p:pic>
+        <p:nvPicPr>
+          <p:cNvPr id="3" name="electric-violet-cover-photo" descr="Documentary work scene used as the cover visual"/>
+          <p:cNvPicPr/>
+          <p:nvPr/>
+        </p:nvPicPr>
+        <p:blipFill>
+          <a:blip xmlns:r="http://schemas.openxmlformats.org/officeDocument/2006/relationships" xmlns:a="http://schemas.openxmlformats.org/drawingml/2006/main" r:embed="rIdOfficeKitImage4df9c6298f17ef7a_1"/>
+          <a:srcRect xmlns:a="http://schemas.openxmlformats.org/drawingml/2006/main" l="0" t="41949" r="0" b="41949"/>
+          <a:stretch xmlns:a="http://schemas.openxmlformats.org/drawingml/2006/main">
+            <a:fillRect/>
+          </a:stretch>
+        </p:blipFill>
+        <p:spPr>
+          <a:xfrm xmlns:a="http://schemas.openxmlformats.org/drawingml/2006/main">
+            <a:off x="0" y="4210050"/>
+            <a:ext cx="15240000" cy="4362450"/>
+          </a:xfrm>
+          <a:prstGeom xmlns:a="http://schemas.openxmlformats.org/drawingml/2006/main" prst="rect">
+            <a:avLst/>
+          </a:prstGeom>
+        </p:spPr>
+      </p:pic>
+      <p:sp>
+        <p:nvSpPr>
+          <p:cNvPr id="4" name="electric-violet-cover-rule"/>
           <p:cNvSpPr/>
           <p:nvPr/>
         </p:nvSpPr>
         <p:spPr>
           <a:xfrm xmlns:a="http://schemas.openxmlformats.org/drawingml/2006/main">
-            <a:off x="838200" y="666750"/>
-            <a:ext cx="13563600" cy="0"/>
+            <a:off x="914400" y="514350"/>
+            <a:ext cx="13411200" cy="0"/>
           </a:xfrm>
           <a:prstGeom xmlns:a="http://schemas.openxmlformats.org/drawingml/2006/main" prst="line">
             <a:avLst/>
@@ -295,29 +306,29 @@
       </p:sp>
       <p:sp>
         <p:nvSpPr>
-          <p:cNvPr id="4" name="eyebrow"/>
-          <p:cNvSpPr txBox="1"/>
-          <p:nvPr/>
-        </p:nvSpPr>
-        <p:spPr>
-          <a:xfrm xmlns:a="http://schemas.openxmlformats.org/drawingml/2006/main">
-            <a:off x="914400" y="895350"/>
-            <a:ext cx="7239000" cy="228600"/>
-          </a:xfrm>
-          <a:prstGeom xmlns:a="http://schemas.openxmlformats.org/drawingml/2006/main" prst="rect">
-            <a:avLst/>
-          </a:prstGeom>
-          <a:noFill xmlns:a="http://schemas.openxmlformats.org/drawingml/2006/main"/>
-          <a:ln xmlns:a="http://schemas.openxmlformats.org/drawingml/2006/main" w="0">
-            <a:noFill/>
-          </a:ln>
-        </p:spPr>
-        <p:txBody>
-          <a:bodyPr xmlns:a="http://schemas.openxmlformats.org/drawingml/2006/main" wrap="square" lIns="0" tIns="0" rIns="0" bIns="0" anchor="t"/>
-          <a:lstStyle xmlns:a="http://schemas.openxmlformats.org/drawingml/2006/main"/>
-          <a:p xmlns:a="http://schemas.openxmlformats.org/drawingml/2006/main">
-            <a:r>
-              <a:rPr lang="en-US" sz="1200" b="1">
+          <p:cNvPr id="5" name="electric-violet-cover-eyebrow"/>
+          <p:cNvSpPr txBox="1"/>
+          <p:nvPr/>
+        </p:nvSpPr>
+        <p:spPr>
+          <a:xfrm xmlns:a="http://schemas.openxmlformats.org/drawingml/2006/main">
+            <a:off x="914400" y="781050"/>
+            <a:ext cx="7239000" cy="209550"/>
+          </a:xfrm>
+          <a:prstGeom xmlns:a="http://schemas.openxmlformats.org/drawingml/2006/main" prst="rect">
+            <a:avLst/>
+          </a:prstGeom>
+          <a:noFill xmlns:a="http://schemas.openxmlformats.org/drawingml/2006/main"/>
+          <a:ln xmlns:a="http://schemas.openxmlformats.org/drawingml/2006/main" w="0">
+            <a:noFill/>
+          </a:ln>
+        </p:spPr>
+        <p:txBody>
+          <a:bodyPr xmlns:a="http://schemas.openxmlformats.org/drawingml/2006/main" wrap="square" lIns="0" tIns="0" rIns="0" bIns="0" anchor="t"/>
+          <a:lstStyle xmlns:a="http://schemas.openxmlformats.org/drawingml/2006/main"/>
+          <a:p xmlns:a="http://schemas.openxmlformats.org/drawingml/2006/main">
+            <a:r>
+              <a:rPr lang="en-US" sz="1050" b="1">
                 <a:solidFill>
                   <a:srgbClr val="7047FF"/>
                 </a:solidFill>
@@ -332,31 +343,31 @@
       </p:sp>
       <p:sp>
         <p:nvSpPr>
-          <p:cNvPr id="5" name="cover-title"/>
-          <p:cNvSpPr txBox="1"/>
-          <p:nvPr/>
-        </p:nvSpPr>
-        <p:spPr>
-          <a:xfrm xmlns:a="http://schemas.openxmlformats.org/drawingml/2006/main">
-            <a:off x="914400" y="1571625"/>
-            <a:ext cx="8382000" cy="1066800"/>
-          </a:xfrm>
-          <a:prstGeom xmlns:a="http://schemas.openxmlformats.org/drawingml/2006/main" prst="rect">
-            <a:avLst/>
-          </a:prstGeom>
-          <a:noFill xmlns:a="http://schemas.openxmlformats.org/drawingml/2006/main"/>
-          <a:ln xmlns:a="http://schemas.openxmlformats.org/drawingml/2006/main" w="0">
-            <a:noFill/>
-          </a:ln>
-        </p:spPr>
-        <p:txBody>
-          <a:bodyPr xmlns:a="http://schemas.openxmlformats.org/drawingml/2006/main" wrap="square" lIns="0" tIns="0" rIns="0" bIns="0" anchor="t"/>
-          <a:lstStyle xmlns:a="http://schemas.openxmlformats.org/drawingml/2006/main"/>
-          <a:p xmlns:a="http://schemas.openxmlformats.org/drawingml/2006/main">
-            <a:r>
-              <a:rPr lang="en-US" sz="3600" b="1">
-                <a:solidFill>
-                  <a:srgbClr val="F8F8F7"/>
+          <p:cNvPr id="6" name="cover-title"/>
+          <p:cNvSpPr txBox="1"/>
+          <p:nvPr/>
+        </p:nvSpPr>
+        <p:spPr>
+          <a:xfrm xmlns:a="http://schemas.openxmlformats.org/drawingml/2006/main">
+            <a:off x="914400" y="1314450"/>
+            <a:ext cx="11620500" cy="742950"/>
+          </a:xfrm>
+          <a:prstGeom xmlns:a="http://schemas.openxmlformats.org/drawingml/2006/main" prst="rect">
+            <a:avLst/>
+          </a:prstGeom>
+          <a:noFill xmlns:a="http://schemas.openxmlformats.org/drawingml/2006/main"/>
+          <a:ln xmlns:a="http://schemas.openxmlformats.org/drawingml/2006/main" w="0">
+            <a:noFill/>
+          </a:ln>
+        </p:spPr>
+        <p:txBody>
+          <a:bodyPr xmlns:a="http://schemas.openxmlformats.org/drawingml/2006/main" wrap="square" lIns="0" tIns="0" rIns="0" bIns="0" anchor="t"/>
+          <a:lstStyle xmlns:a="http://schemas.openxmlformats.org/drawingml/2006/main"/>
+          <a:p xmlns:a="http://schemas.openxmlformats.org/drawingml/2006/main">
+            <a:r>
+              <a:rPr lang="en-US" sz="3150" b="1">
+                <a:solidFill>
+                  <a:srgbClr val="FFFFFF"/>
                 </a:solidFill>
                 <a:latin typeface="Tahoma"/>
                 <a:ea typeface="Tahoma"/>
@@ -369,241 +380,56 @@
       </p:sp>
       <p:sp>
         <p:nvSpPr>
-          <p:cNvPr id="6" name="cover-subtitle"/>
-          <p:cNvSpPr txBox="1"/>
-          <p:nvPr/>
-        </p:nvSpPr>
-        <p:spPr>
-          <a:xfrm xmlns:a="http://schemas.openxmlformats.org/drawingml/2006/main">
-            <a:off x="952500" y="2857500"/>
-            <a:ext cx="6858000" cy="323850"/>
-          </a:xfrm>
-          <a:prstGeom xmlns:a="http://schemas.openxmlformats.org/drawingml/2006/main" prst="rect">
-            <a:avLst/>
-          </a:prstGeom>
-          <a:noFill xmlns:a="http://schemas.openxmlformats.org/drawingml/2006/main"/>
-          <a:ln xmlns:a="http://schemas.openxmlformats.org/drawingml/2006/main" w="0">
-            <a:noFill/>
-          </a:ln>
-        </p:spPr>
-        <p:txBody>
-          <a:bodyPr xmlns:a="http://schemas.openxmlformats.org/drawingml/2006/main" wrap="square" lIns="0" tIns="0" rIns="0" bIns="0" anchor="t"/>
-          <a:lstStyle xmlns:a="http://schemas.openxmlformats.org/drawingml/2006/main"/>
-          <a:p xmlns:a="http://schemas.openxmlformats.org/drawingml/2006/main">
-            <a:r>
-              <a:rPr lang="en-US" sz="1725">
-                <a:solidFill>
-                  <a:srgbClr val="7047FF"/>
-                </a:solidFill>
-                <a:latin typeface="Tahoma"/>
-                <a:ea typeface="Tahoma"/>
-              </a:rPr>
-              <a:t>A clean-room reference for evidence, direction, and a decision.</a:t>
-            </a:r>
-            <a:endParaRPr lang="en-US"/>
-          </a:p>
-        </p:txBody>
-      </p:sp>
-      <p:sp>
-        <p:nvSpPr>
-          <p:cNvPr id="7" name="cover-rule"/>
+          <p:cNvPr id="7" name="electric-violet-cover-basis"/>
+          <p:cNvSpPr txBox="1"/>
+          <p:nvPr/>
+        </p:nvSpPr>
+        <p:spPr>
+          <a:xfrm xmlns:a="http://schemas.openxmlformats.org/drawingml/2006/main">
+            <a:off x="952500" y="2457450"/>
+            <a:ext cx="8763000" cy="266700"/>
+          </a:xfrm>
+          <a:prstGeom xmlns:a="http://schemas.openxmlformats.org/drawingml/2006/main" prst="rect">
+            <a:avLst/>
+          </a:prstGeom>
+          <a:noFill xmlns:a="http://schemas.openxmlformats.org/drawingml/2006/main"/>
+          <a:ln xmlns:a="http://schemas.openxmlformats.org/drawingml/2006/main" w="0">
+            <a:noFill/>
+          </a:ln>
+        </p:spPr>
+        <p:txBody>
+          <a:bodyPr xmlns:a="http://schemas.openxmlformats.org/drawingml/2006/main" wrap="square" lIns="0" tIns="0" rIns="0" bIns="0" anchor="t"/>
+          <a:lstStyle xmlns:a="http://schemas.openxmlformats.org/drawingml/2006/main"/>
+          <a:p xmlns:a="http://schemas.openxmlformats.org/drawingml/2006/main">
+            <a:r>
+              <a:rPr lang="en-US" sz="1425">
+                <a:solidFill>
+                  <a:srgbClr val="B9B9B9"/>
+                </a:solidFill>
+                <a:latin typeface="Tahoma"/>
+                <a:ea typeface="Tahoma"/>
+              </a:rPr>
+              <a:t>A documentary operating review turns status into a decision.</a:t>
+            </a:r>
+            <a:endParaRPr lang="en-US"/>
+          </a:p>
+        </p:txBody>
+      </p:sp>
+      <p:sp>
+        <p:nvSpPr>
+          <p:cNvPr id="8" name="electric-violet-cover-photo-rule"/>
           <p:cNvSpPr/>
           <p:nvPr/>
         </p:nvSpPr>
         <p:spPr>
           <a:xfrm xmlns:a="http://schemas.openxmlformats.org/drawingml/2006/main">
-            <a:off x="914400" y="3524250"/>
-            <a:ext cx="7658100" cy="0"/>
+            <a:off x="914400" y="3886200"/>
+            <a:ext cx="13411200" cy="0"/>
           </a:xfrm>
           <a:prstGeom xmlns:a="http://schemas.openxmlformats.org/drawingml/2006/main" prst="line">
             <a:avLst/>
           </a:prstGeom>
           <a:noFill xmlns:a="http://schemas.openxmlformats.org/drawingml/2006/main"/>
-          <a:ln xmlns:a="http://schemas.openxmlformats.org/drawingml/2006/main" w="25400">
-            <a:solidFill>
-              <a:srgbClr val="7F8081"/>
-            </a:solidFill>
-            <a:prstDash val="solid"/>
-          </a:ln>
-        </p:spPr>
-        <p:txBody>
-          <a:bodyPr xmlns:a="http://schemas.openxmlformats.org/drawingml/2006/main" wrap="square" lIns="0" tIns="0" rIns="0" bIns="0" anchor="t"/>
-          <a:lstStyle xmlns:a="http://schemas.openxmlformats.org/drawingml/2006/main"/>
-          <a:p xmlns:a="http://schemas.openxmlformats.org/drawingml/2006/main">
-            <a:r>
-              <a:rPr lang="en-US"/>
-              <a:t/>
-            </a:r>
-            <a:endParaRPr lang="en-US"/>
-          </a:p>
-        </p:txBody>
-      </p:sp>
-      <p:sp>
-        <p:nvSpPr>
-          <p:cNvPr id="8" name="cover-basis"/>
-          <p:cNvSpPr txBox="1"/>
-          <p:nvPr/>
-        </p:nvSpPr>
-        <p:spPr>
-          <a:xfrm xmlns:a="http://schemas.openxmlformats.org/drawingml/2006/main">
-            <a:off x="952500" y="3762375"/>
-            <a:ext cx="7810500" cy="266700"/>
-          </a:xfrm>
-          <a:prstGeom xmlns:a="http://schemas.openxmlformats.org/drawingml/2006/main" prst="rect">
-            <a:avLst/>
-          </a:prstGeom>
-          <a:noFill xmlns:a="http://schemas.openxmlformats.org/drawingml/2006/main"/>
-          <a:ln xmlns:a="http://schemas.openxmlformats.org/drawingml/2006/main" w="0">
-            <a:noFill/>
-          </a:ln>
-        </p:spPr>
-        <p:txBody>
-          <a:bodyPr xmlns:a="http://schemas.openxmlformats.org/drawingml/2006/main" wrap="square" lIns="0" tIns="0" rIns="0" bIns="0" anchor="t"/>
-          <a:lstStyle xmlns:a="http://schemas.openxmlformats.org/drawingml/2006/main"/>
-          <a:p xmlns:a="http://schemas.openxmlformats.org/drawingml/2006/main">
-            <a:r>
-              <a:rPr lang="en-US" sz="1350">
-                <a:solidFill>
-                  <a:srgbClr val="F8F8F7"/>
-                </a:solidFill>
-                <a:latin typeface="Tahoma"/>
-                <a:ea typeface="Tahoma"/>
-              </a:rPr>
-              <a:t>One visual language · four page roles · native editable objects</a:t>
-            </a:r>
-            <a:endParaRPr lang="en-US"/>
-          </a:p>
-        </p:txBody>
-      </p:sp>
-      <p:sp>
-        <p:nvSpPr>
-          <p:cNvPr id="9" name="cover-thesis"/>
-          <p:cNvSpPr txBox="1"/>
-          <p:nvPr/>
-        </p:nvSpPr>
-        <p:spPr>
-          <a:xfrm xmlns:a="http://schemas.openxmlformats.org/drawingml/2006/main">
-            <a:off x="952500" y="4810125"/>
-            <a:ext cx="6667500" cy="628650"/>
-          </a:xfrm>
-          <a:prstGeom xmlns:a="http://schemas.openxmlformats.org/drawingml/2006/main" prst="rect">
-            <a:avLst/>
-          </a:prstGeom>
-          <a:noFill xmlns:a="http://schemas.openxmlformats.org/drawingml/2006/main"/>
-          <a:ln xmlns:a="http://schemas.openxmlformats.org/drawingml/2006/main" w="0">
-            <a:noFill/>
-          </a:ln>
-        </p:spPr>
-        <p:txBody>
-          <a:bodyPr xmlns:a="http://schemas.openxmlformats.org/drawingml/2006/main" wrap="square" lIns="0" tIns="0" rIns="0" bIns="0" anchor="t"/>
-          <a:lstStyle xmlns:a="http://schemas.openxmlformats.org/drawingml/2006/main"/>
-          <a:p xmlns:a="http://schemas.openxmlformats.org/drawingml/2006/main">
-            <a:r>
-              <a:rPr lang="en-US" sz="1875" b="1">
-                <a:solidFill>
-                  <a:srgbClr val="F8F8F7"/>
-                </a:solidFill>
-                <a:latin typeface="Tahoma"/>
-                <a:ea typeface="Tahoma"/>
-              </a:rPr>
-              <a:t>A visible operating signal creates a shared next action.</a:t>
-            </a:r>
-            <a:endParaRPr lang="en-US"/>
-          </a:p>
-        </p:txBody>
-      </p:sp>
-      <p:sp>
-        <p:nvSpPr>
-          <p:cNvPr id="10" name="cover-source"/>
-          <p:cNvSpPr txBox="1"/>
-          <p:nvPr/>
-        </p:nvSpPr>
-        <p:spPr>
-          <a:xfrm xmlns:a="http://schemas.openxmlformats.org/drawingml/2006/main">
-            <a:off x="952500" y="7315200"/>
-            <a:ext cx="9048750" cy="228600"/>
-          </a:xfrm>
-          <a:prstGeom xmlns:a="http://schemas.openxmlformats.org/drawingml/2006/main" prst="rect">
-            <a:avLst/>
-          </a:prstGeom>
-          <a:noFill xmlns:a="http://schemas.openxmlformats.org/drawingml/2006/main"/>
-          <a:ln xmlns:a="http://schemas.openxmlformats.org/drawingml/2006/main" w="0">
-            <a:noFill/>
-          </a:ln>
-        </p:spPr>
-        <p:txBody>
-          <a:bodyPr xmlns:a="http://schemas.openxmlformats.org/drawingml/2006/main" wrap="square" lIns="0" tIns="0" rIns="0" bIns="0" anchor="t"/>
-          <a:lstStyle xmlns:a="http://schemas.openxmlformats.org/drawingml/2006/main"/>
-          <a:p xmlns:a="http://schemas.openxmlformats.org/drawingml/2006/main">
-            <a:r>
-              <a:rPr lang="en-US" sz="1050">
-                <a:solidFill>
-                  <a:srgbClr val="7F8081"/>
-                </a:solidFill>
-                <a:latin typeface="Tahoma"/>
-                <a:ea typeface="Tahoma"/>
-              </a:rPr>
-              <a:t>OfficeKit original clean-room calibration · fictional content · 2026-08-29</a:t>
-            </a:r>
-            <a:endParaRPr lang="en-US"/>
-          </a:p>
-        </p:txBody>
-      </p:sp>
-      <p:sp>
-        <p:nvSpPr>
-          <p:cNvPr id="11" name="page-number"/>
-          <p:cNvSpPr txBox="1"/>
-          <p:nvPr/>
-        </p:nvSpPr>
-        <p:spPr>
-          <a:xfrm xmlns:a="http://schemas.openxmlformats.org/drawingml/2006/main">
-            <a:off x="13335000" y="7810500"/>
-            <a:ext cx="952500" cy="209550"/>
-          </a:xfrm>
-          <a:prstGeom xmlns:a="http://schemas.openxmlformats.org/drawingml/2006/main" prst="rect">
-            <a:avLst/>
-          </a:prstGeom>
-          <a:noFill xmlns:a="http://schemas.openxmlformats.org/drawingml/2006/main"/>
-          <a:ln xmlns:a="http://schemas.openxmlformats.org/drawingml/2006/main" w="0">
-            <a:noFill/>
-          </a:ln>
-        </p:spPr>
-        <p:txBody>
-          <a:bodyPr xmlns:a="http://schemas.openxmlformats.org/drawingml/2006/main" wrap="square" lIns="0" tIns="0" rIns="0" bIns="0" anchor="t"/>
-          <a:lstStyle xmlns:a="http://schemas.openxmlformats.org/drawingml/2006/main"/>
-          <a:p xmlns:a="http://schemas.openxmlformats.org/drawingml/2006/main">
-            <a:pPr algn="r"/>
-            <a:r>
-              <a:rPr lang="en-US" sz="1050">
-                <a:solidFill>
-                  <a:srgbClr val="7F8081"/>
-                </a:solidFill>
-                <a:latin typeface="Tahoma"/>
-                <a:ea typeface="Tahoma"/>
-              </a:rPr>
-              <a:t>1 / 6</a:t>
-            </a:r>
-            <a:endParaRPr lang="en-US"/>
-          </a:p>
-        </p:txBody>
-      </p:sp>
-      <p:sp>
-        <p:nvSpPr>
-          <p:cNvPr id="12" name="anchor-field"/>
-          <p:cNvSpPr/>
-          <p:nvPr/>
-        </p:nvSpPr>
-        <p:spPr>
-          <a:xfrm xmlns:a="http://schemas.openxmlformats.org/drawingml/2006/main">
-            <a:off x="11620500" y="1790700"/>
-            <a:ext cx="2095500" cy="2286000"/>
-          </a:xfrm>
-          <a:prstGeom xmlns:a="http://schemas.openxmlformats.org/drawingml/2006/main" prst="rect">
-            <a:avLst/>
-          </a:prstGeom>
-          <a:solidFill xmlns:a="http://schemas.openxmlformats.org/drawingml/2006/main">
-            <a:srgbClr val="F3F5F8"/>
-          </a:solidFill>
           <a:ln xmlns:a="http://schemas.openxmlformats.org/drawingml/2006/main" w="25400">
             <a:solidFill>
               <a:srgbClr val="7047FF"/>
@@ -625,357 +451,111 @@
       </p:sp>
       <p:sp>
         <p:nvSpPr>
-          <p:cNvPr id="13" name="anchor-grid-0-0"/>
-          <p:cNvSpPr/>
-          <p:nvPr/>
-        </p:nvSpPr>
-        <p:spPr>
-          <a:xfrm xmlns:a="http://schemas.openxmlformats.org/drawingml/2006/main">
-            <a:off x="11925300" y="2152650"/>
-            <a:ext cx="266700" cy="285750"/>
-          </a:xfrm>
-          <a:prstGeom xmlns:a="http://schemas.openxmlformats.org/drawingml/2006/main" prst="rect">
-            <a:avLst/>
-          </a:prstGeom>
-          <a:solidFill xmlns:a="http://schemas.openxmlformats.org/drawingml/2006/main">
-            <a:srgbClr val="7047FF"/>
-          </a:solidFill>
-          <a:ln xmlns:a="http://schemas.openxmlformats.org/drawingml/2006/main" w="12700">
-            <a:solidFill>
-              <a:srgbClr val="7047FF"/>
-            </a:solidFill>
-            <a:prstDash val="solid"/>
-          </a:ln>
-        </p:spPr>
-        <p:txBody>
-          <a:bodyPr xmlns:a="http://schemas.openxmlformats.org/drawingml/2006/main" wrap="square" lIns="0" tIns="0" rIns="0" bIns="0" anchor="t"/>
-          <a:lstStyle xmlns:a="http://schemas.openxmlformats.org/drawingml/2006/main"/>
-          <a:p xmlns:a="http://schemas.openxmlformats.org/drawingml/2006/main">
-            <a:r>
-              <a:rPr lang="en-US"/>
-              <a:t/>
-            </a:r>
-            <a:endParaRPr lang="en-US"/>
-          </a:p>
-        </p:txBody>
-      </p:sp>
-      <p:sp>
-        <p:nvSpPr>
-          <p:cNvPr id="14" name="anchor-grid-0-1"/>
-          <p:cNvSpPr/>
-          <p:nvPr/>
-        </p:nvSpPr>
-        <p:spPr>
-          <a:xfrm xmlns:a="http://schemas.openxmlformats.org/drawingml/2006/main">
-            <a:off x="12420600" y="2152650"/>
-            <a:ext cx="266700" cy="285750"/>
-          </a:xfrm>
-          <a:prstGeom xmlns:a="http://schemas.openxmlformats.org/drawingml/2006/main" prst="rect">
-            <a:avLst/>
-          </a:prstGeom>
-          <a:solidFill xmlns:a="http://schemas.openxmlformats.org/drawingml/2006/main">
-            <a:srgbClr val="7047FF"/>
-          </a:solidFill>
-          <a:ln xmlns:a="http://schemas.openxmlformats.org/drawingml/2006/main" w="12700">
-            <a:solidFill>
-              <a:srgbClr val="7047FF"/>
-            </a:solidFill>
-            <a:prstDash val="solid"/>
-          </a:ln>
-        </p:spPr>
-        <p:txBody>
-          <a:bodyPr xmlns:a="http://schemas.openxmlformats.org/drawingml/2006/main" wrap="square" lIns="0" tIns="0" rIns="0" bIns="0" anchor="t"/>
-          <a:lstStyle xmlns:a="http://schemas.openxmlformats.org/drawingml/2006/main"/>
-          <a:p xmlns:a="http://schemas.openxmlformats.org/drawingml/2006/main">
-            <a:r>
-              <a:rPr lang="en-US"/>
-              <a:t/>
-            </a:r>
-            <a:endParaRPr lang="en-US"/>
-          </a:p>
-        </p:txBody>
-      </p:sp>
-      <p:sp>
-        <p:nvSpPr>
-          <p:cNvPr id="15" name="anchor-grid-0-2"/>
-          <p:cNvSpPr/>
-          <p:nvPr/>
-        </p:nvSpPr>
-        <p:spPr>
-          <a:xfrm xmlns:a="http://schemas.openxmlformats.org/drawingml/2006/main">
-            <a:off x="12915900" y="2152650"/>
-            <a:ext cx="266700" cy="285750"/>
-          </a:xfrm>
-          <a:prstGeom xmlns:a="http://schemas.openxmlformats.org/drawingml/2006/main" prst="rect">
-            <a:avLst/>
-          </a:prstGeom>
-          <a:solidFill xmlns:a="http://schemas.openxmlformats.org/drawingml/2006/main">
-            <a:srgbClr val="101115"/>
-          </a:solidFill>
-          <a:ln xmlns:a="http://schemas.openxmlformats.org/drawingml/2006/main" w="12700">
-            <a:solidFill>
-              <a:srgbClr val="7047FF"/>
-            </a:solidFill>
-            <a:prstDash val="solid"/>
-          </a:ln>
-        </p:spPr>
-        <p:txBody>
-          <a:bodyPr xmlns:a="http://schemas.openxmlformats.org/drawingml/2006/main" wrap="square" lIns="0" tIns="0" rIns="0" bIns="0" anchor="t"/>
-          <a:lstStyle xmlns:a="http://schemas.openxmlformats.org/drawingml/2006/main"/>
-          <a:p xmlns:a="http://schemas.openxmlformats.org/drawingml/2006/main">
-            <a:r>
-              <a:rPr lang="en-US"/>
-              <a:t/>
-            </a:r>
-            <a:endParaRPr lang="en-US"/>
-          </a:p>
-        </p:txBody>
-      </p:sp>
-      <p:sp>
-        <p:nvSpPr>
-          <p:cNvPr id="16" name="anchor-grid-1-0"/>
-          <p:cNvSpPr/>
-          <p:nvPr/>
-        </p:nvSpPr>
-        <p:spPr>
-          <a:xfrm xmlns:a="http://schemas.openxmlformats.org/drawingml/2006/main">
-            <a:off x="11925300" y="2686050"/>
-            <a:ext cx="266700" cy="285750"/>
-          </a:xfrm>
-          <a:prstGeom xmlns:a="http://schemas.openxmlformats.org/drawingml/2006/main" prst="rect">
-            <a:avLst/>
-          </a:prstGeom>
-          <a:solidFill xmlns:a="http://schemas.openxmlformats.org/drawingml/2006/main">
-            <a:srgbClr val="7047FF"/>
-          </a:solidFill>
-          <a:ln xmlns:a="http://schemas.openxmlformats.org/drawingml/2006/main" w="12700">
-            <a:solidFill>
-              <a:srgbClr val="7047FF"/>
-            </a:solidFill>
-            <a:prstDash val="solid"/>
-          </a:ln>
-        </p:spPr>
-        <p:txBody>
-          <a:bodyPr xmlns:a="http://schemas.openxmlformats.org/drawingml/2006/main" wrap="square" lIns="0" tIns="0" rIns="0" bIns="0" anchor="t"/>
-          <a:lstStyle xmlns:a="http://schemas.openxmlformats.org/drawingml/2006/main"/>
-          <a:p xmlns:a="http://schemas.openxmlformats.org/drawingml/2006/main">
-            <a:r>
-              <a:rPr lang="en-US"/>
-              <a:t/>
-            </a:r>
-            <a:endParaRPr lang="en-US"/>
-          </a:p>
-        </p:txBody>
-      </p:sp>
-      <p:sp>
-        <p:nvSpPr>
-          <p:cNvPr id="17" name="anchor-grid-1-1"/>
-          <p:cNvSpPr/>
-          <p:nvPr/>
-        </p:nvSpPr>
-        <p:spPr>
-          <a:xfrm xmlns:a="http://schemas.openxmlformats.org/drawingml/2006/main">
-            <a:off x="12420600" y="2686050"/>
-            <a:ext cx="266700" cy="285750"/>
-          </a:xfrm>
-          <a:prstGeom xmlns:a="http://schemas.openxmlformats.org/drawingml/2006/main" prst="rect">
-            <a:avLst/>
-          </a:prstGeom>
-          <a:solidFill xmlns:a="http://schemas.openxmlformats.org/drawingml/2006/main">
-            <a:srgbClr val="7047FF"/>
-          </a:solidFill>
-          <a:ln xmlns:a="http://schemas.openxmlformats.org/drawingml/2006/main" w="12700">
-            <a:solidFill>
-              <a:srgbClr val="7047FF"/>
-            </a:solidFill>
-            <a:prstDash val="solid"/>
-          </a:ln>
-        </p:spPr>
-        <p:txBody>
-          <a:bodyPr xmlns:a="http://schemas.openxmlformats.org/drawingml/2006/main" wrap="square" lIns="0" tIns="0" rIns="0" bIns="0" anchor="t"/>
-          <a:lstStyle xmlns:a="http://schemas.openxmlformats.org/drawingml/2006/main"/>
-          <a:p xmlns:a="http://schemas.openxmlformats.org/drawingml/2006/main">
-            <a:r>
-              <a:rPr lang="en-US"/>
-              <a:t/>
-            </a:r>
-            <a:endParaRPr lang="en-US"/>
-          </a:p>
-        </p:txBody>
-      </p:sp>
-      <p:sp>
-        <p:nvSpPr>
-          <p:cNvPr id="18" name="anchor-grid-1-2"/>
-          <p:cNvSpPr/>
-          <p:nvPr/>
-        </p:nvSpPr>
-        <p:spPr>
-          <a:xfrm xmlns:a="http://schemas.openxmlformats.org/drawingml/2006/main">
-            <a:off x="12915900" y="2686050"/>
-            <a:ext cx="266700" cy="285750"/>
-          </a:xfrm>
-          <a:prstGeom xmlns:a="http://schemas.openxmlformats.org/drawingml/2006/main" prst="rect">
-            <a:avLst/>
-          </a:prstGeom>
-          <a:solidFill xmlns:a="http://schemas.openxmlformats.org/drawingml/2006/main">
-            <a:srgbClr val="101115"/>
-          </a:solidFill>
-          <a:ln xmlns:a="http://schemas.openxmlformats.org/drawingml/2006/main" w="12700">
-            <a:solidFill>
-              <a:srgbClr val="7047FF"/>
-            </a:solidFill>
-            <a:prstDash val="solid"/>
-          </a:ln>
-        </p:spPr>
-        <p:txBody>
-          <a:bodyPr xmlns:a="http://schemas.openxmlformats.org/drawingml/2006/main" wrap="square" lIns="0" tIns="0" rIns="0" bIns="0" anchor="t"/>
-          <a:lstStyle xmlns:a="http://schemas.openxmlformats.org/drawingml/2006/main"/>
-          <a:p xmlns:a="http://schemas.openxmlformats.org/drawingml/2006/main">
-            <a:r>
-              <a:rPr lang="en-US"/>
-              <a:t/>
-            </a:r>
-            <a:endParaRPr lang="en-US"/>
-          </a:p>
-        </p:txBody>
-      </p:sp>
-      <p:sp>
-        <p:nvSpPr>
-          <p:cNvPr id="19" name="anchor-grid-2-0"/>
-          <p:cNvSpPr/>
-          <p:nvPr/>
-        </p:nvSpPr>
-        <p:spPr>
-          <a:xfrm xmlns:a="http://schemas.openxmlformats.org/drawingml/2006/main">
-            <a:off x="11925300" y="3219450"/>
-            <a:ext cx="266700" cy="285750"/>
-          </a:xfrm>
-          <a:prstGeom xmlns:a="http://schemas.openxmlformats.org/drawingml/2006/main" prst="rect">
-            <a:avLst/>
-          </a:prstGeom>
-          <a:solidFill xmlns:a="http://schemas.openxmlformats.org/drawingml/2006/main">
-            <a:srgbClr val="7047FF"/>
-          </a:solidFill>
-          <a:ln xmlns:a="http://schemas.openxmlformats.org/drawingml/2006/main" w="12700">
-            <a:solidFill>
-              <a:srgbClr val="7047FF"/>
-            </a:solidFill>
-            <a:prstDash val="solid"/>
-          </a:ln>
-        </p:spPr>
-        <p:txBody>
-          <a:bodyPr xmlns:a="http://schemas.openxmlformats.org/drawingml/2006/main" wrap="square" lIns="0" tIns="0" rIns="0" bIns="0" anchor="t"/>
-          <a:lstStyle xmlns:a="http://schemas.openxmlformats.org/drawingml/2006/main"/>
-          <a:p xmlns:a="http://schemas.openxmlformats.org/drawingml/2006/main">
-            <a:r>
-              <a:rPr lang="en-US"/>
-              <a:t/>
-            </a:r>
-            <a:endParaRPr lang="en-US"/>
-          </a:p>
-        </p:txBody>
-      </p:sp>
-      <p:sp>
-        <p:nvSpPr>
-          <p:cNvPr id="20" name="anchor-grid-2-1"/>
-          <p:cNvSpPr/>
-          <p:nvPr/>
-        </p:nvSpPr>
-        <p:spPr>
-          <a:xfrm xmlns:a="http://schemas.openxmlformats.org/drawingml/2006/main">
-            <a:off x="12420600" y="3219450"/>
-            <a:ext cx="266700" cy="285750"/>
-          </a:xfrm>
-          <a:prstGeom xmlns:a="http://schemas.openxmlformats.org/drawingml/2006/main" prst="rect">
-            <a:avLst/>
-          </a:prstGeom>
-          <a:solidFill xmlns:a="http://schemas.openxmlformats.org/drawingml/2006/main">
-            <a:srgbClr val="7047FF"/>
-          </a:solidFill>
-          <a:ln xmlns:a="http://schemas.openxmlformats.org/drawingml/2006/main" w="12700">
-            <a:solidFill>
-              <a:srgbClr val="7047FF"/>
-            </a:solidFill>
-            <a:prstDash val="solid"/>
-          </a:ln>
-        </p:spPr>
-        <p:txBody>
-          <a:bodyPr xmlns:a="http://schemas.openxmlformats.org/drawingml/2006/main" wrap="square" lIns="0" tIns="0" rIns="0" bIns="0" anchor="t"/>
-          <a:lstStyle xmlns:a="http://schemas.openxmlformats.org/drawingml/2006/main"/>
-          <a:p xmlns:a="http://schemas.openxmlformats.org/drawingml/2006/main">
-            <a:r>
-              <a:rPr lang="en-US"/>
-              <a:t/>
-            </a:r>
-            <a:endParaRPr lang="en-US"/>
-          </a:p>
-        </p:txBody>
-      </p:sp>
-      <p:sp>
-        <p:nvSpPr>
-          <p:cNvPr id="21" name="anchor-grid-2-2"/>
-          <p:cNvSpPr/>
-          <p:nvPr/>
-        </p:nvSpPr>
-        <p:spPr>
-          <a:xfrm xmlns:a="http://schemas.openxmlformats.org/drawingml/2006/main">
-            <a:off x="12915900" y="3219450"/>
-            <a:ext cx="266700" cy="285750"/>
-          </a:xfrm>
-          <a:prstGeom xmlns:a="http://schemas.openxmlformats.org/drawingml/2006/main" prst="rect">
-            <a:avLst/>
-          </a:prstGeom>
-          <a:solidFill xmlns:a="http://schemas.openxmlformats.org/drawingml/2006/main">
-            <a:srgbClr val="101115"/>
-          </a:solidFill>
-          <a:ln xmlns:a="http://schemas.openxmlformats.org/drawingml/2006/main" w="12700">
-            <a:solidFill>
-              <a:srgbClr val="7047FF"/>
-            </a:solidFill>
-            <a:prstDash val="solid"/>
-          </a:ln>
-        </p:spPr>
-        <p:txBody>
-          <a:bodyPr xmlns:a="http://schemas.openxmlformats.org/drawingml/2006/main" wrap="square" lIns="0" tIns="0" rIns="0" bIns="0" anchor="t"/>
-          <a:lstStyle xmlns:a="http://schemas.openxmlformats.org/drawingml/2006/main"/>
-          <a:p xmlns:a="http://schemas.openxmlformats.org/drawingml/2006/main">
-            <a:r>
-              <a:rPr lang="en-US"/>
-              <a:t/>
-            </a:r>
-            <a:endParaRPr lang="en-US"/>
-          </a:p>
-        </p:txBody>
-      </p:sp>
-      <p:sp>
-        <p:nvSpPr>
-          <p:cNvPr id="22" name="anchor-axis"/>
-          <p:cNvSpPr/>
-          <p:nvPr/>
-        </p:nvSpPr>
-        <p:spPr>
-          <a:xfrm xmlns:a="http://schemas.openxmlformats.org/drawingml/2006/main">
-            <a:off x="12668250" y="1638300"/>
-            <a:ext cx="0" cy="2743200"/>
-          </a:xfrm>
-          <a:prstGeom xmlns:a="http://schemas.openxmlformats.org/drawingml/2006/main" prst="line">
-            <a:avLst/>
-          </a:prstGeom>
-          <a:noFill xmlns:a="http://schemas.openxmlformats.org/drawingml/2006/main"/>
-          <a:ln xmlns:a="http://schemas.openxmlformats.org/drawingml/2006/main" w="50800">
-            <a:solidFill>
-              <a:srgbClr val="F8F8F7"/>
-            </a:solidFill>
-            <a:prstDash val="solid"/>
-          </a:ln>
-        </p:spPr>
-        <p:txBody>
-          <a:bodyPr xmlns:a="http://schemas.openxmlformats.org/drawingml/2006/main" wrap="square" lIns="0" tIns="0" rIns="0" bIns="0" anchor="t"/>
-          <a:lstStyle xmlns:a="http://schemas.openxmlformats.org/drawingml/2006/main"/>
-          <a:p xmlns:a="http://schemas.openxmlformats.org/drawingml/2006/main">
-            <a:r>
-              <a:rPr lang="en-US"/>
-              <a:t/>
+          <p:cNvPr id="9" name="electric-violet-cover-photo-label"/>
+          <p:cNvSpPr txBox="1"/>
+          <p:nvPr/>
+        </p:nvSpPr>
+        <p:spPr>
+          <a:xfrm xmlns:a="http://schemas.openxmlformats.org/drawingml/2006/main">
+            <a:off x="914400" y="3981450"/>
+            <a:ext cx="7810500" cy="190500"/>
+          </a:xfrm>
+          <a:prstGeom xmlns:a="http://schemas.openxmlformats.org/drawingml/2006/main" prst="rect">
+            <a:avLst/>
+          </a:prstGeom>
+          <a:noFill xmlns:a="http://schemas.openxmlformats.org/drawingml/2006/main"/>
+          <a:ln xmlns:a="http://schemas.openxmlformats.org/drawingml/2006/main" w="0">
+            <a:noFill/>
+          </a:ln>
+        </p:spPr>
+        <p:txBody>
+          <a:bodyPr xmlns:a="http://schemas.openxmlformats.org/drawingml/2006/main" wrap="square" lIns="0" tIns="0" rIns="0" bIns="0" anchor="t"/>
+          <a:lstStyle xmlns:a="http://schemas.openxmlformats.org/drawingml/2006/main"/>
+          <a:p xmlns:a="http://schemas.openxmlformats.org/drawingml/2006/main">
+            <a:r>
+              <a:rPr lang="en-US" sz="975" b="1">
+                <a:solidFill>
+                  <a:srgbClr val="B9B9B9"/>
+                </a:solidFill>
+                <a:latin typeface="Tahoma"/>
+                <a:ea typeface="Tahoma"/>
+              </a:rPr>
+              <a:t>MEASURED WORK · VISIBLE CONSEQUENCE</a:t>
+            </a:r>
+            <a:endParaRPr lang="en-US"/>
+          </a:p>
+        </p:txBody>
+      </p:sp>
+      <p:sp>
+        <p:nvSpPr>
+          <p:cNvPr id="10" name="electric-violet-cover-source"/>
+          <p:cNvSpPr txBox="1"/>
+          <p:nvPr/>
+        </p:nvSpPr>
+        <p:spPr>
+          <a:xfrm xmlns:a="http://schemas.openxmlformats.org/drawingml/2006/main">
+            <a:off x="914400" y="7829550"/>
+            <a:ext cx="10953750" cy="209550"/>
+          </a:xfrm>
+          <a:prstGeom xmlns:a="http://schemas.openxmlformats.org/drawingml/2006/main" prst="rect">
+            <a:avLst/>
+          </a:prstGeom>
+          <a:noFill xmlns:a="http://schemas.openxmlformats.org/drawingml/2006/main"/>
+          <a:ln xmlns:a="http://schemas.openxmlformats.org/drawingml/2006/main" w="0">
+            <a:noFill/>
+          </a:ln>
+        </p:spPr>
+        <p:txBody>
+          <a:bodyPr xmlns:a="http://schemas.openxmlformats.org/drawingml/2006/main" wrap="square" lIns="0" tIns="0" rIns="0" bIns="0" anchor="t"/>
+          <a:lstStyle xmlns:a="http://schemas.openxmlformats.org/drawingml/2006/main"/>
+          <a:p xmlns:a="http://schemas.openxmlformats.org/drawingml/2006/main">
+            <a:r>
+              <a:rPr lang="en-US" sz="1050">
+                <a:solidFill>
+                  <a:srgbClr val="B9B9B9"/>
+                </a:solidFill>
+                <a:latin typeface="Tahoma"/>
+                <a:ea typeface="Tahoma"/>
+              </a:rPr>
+              <a:t>OfficeKit original clean-room calibration · fictional content · 2026-08-29</a:t>
+            </a:r>
+            <a:endParaRPr lang="en-US"/>
+          </a:p>
+        </p:txBody>
+      </p:sp>
+      <p:sp>
+        <p:nvSpPr>
+          <p:cNvPr id="11" name="electric-violet-cover-page-number"/>
+          <p:cNvSpPr txBox="1"/>
+          <p:nvPr/>
+        </p:nvSpPr>
+        <p:spPr>
+          <a:xfrm xmlns:a="http://schemas.openxmlformats.org/drawingml/2006/main">
+            <a:off x="13335000" y="7829550"/>
+            <a:ext cx="952500" cy="209550"/>
+          </a:xfrm>
+          <a:prstGeom xmlns:a="http://schemas.openxmlformats.org/drawingml/2006/main" prst="rect">
+            <a:avLst/>
+          </a:prstGeom>
+          <a:noFill xmlns:a="http://schemas.openxmlformats.org/drawingml/2006/main"/>
+          <a:ln xmlns:a="http://schemas.openxmlformats.org/drawingml/2006/main" w="0">
+            <a:noFill/>
+          </a:ln>
+        </p:spPr>
+        <p:txBody>
+          <a:bodyPr xmlns:a="http://schemas.openxmlformats.org/drawingml/2006/main" wrap="square" lIns="0" tIns="0" rIns="0" bIns="0" anchor="t"/>
+          <a:lstStyle xmlns:a="http://schemas.openxmlformats.org/drawingml/2006/main"/>
+          <a:p xmlns:a="http://schemas.openxmlformats.org/drawingml/2006/main">
+            <a:pPr algn="r"/>
+            <a:r>
+              <a:rPr lang="en-US" sz="1050">
+                <a:solidFill>
+                  <a:srgbClr val="B9B9B9"/>
+                </a:solidFill>
+                <a:latin typeface="Tahoma"/>
+                <a:ea typeface="Tahoma"/>
+              </a:rPr>
+              <a:t>1 / 6</a:t>
             </a:r>
             <a:endParaRPr lang="en-US"/>
           </a:p>

</xml_diff>